<commit_message>
Add Eat App column to competitor comparison table
Slide 8 now compares DineEase against Eat App, OpenTable,
TheFork/Quandoo and Klisto. Eat App: flat subscription, no per-cover
commission, restaurant-specialised, USD-priced, limited consumer app.

Co-Authored-By: Claude Opus 4.8 <noreply@anthropic.com>
Claude-Session: https://claude.ai/code/session_01CyhSA8ZRVEByeRTLp2jTDH
</commit_message>
<xml_diff>
--- a/presentation/DineEase-Partner-Presentation.pptx
+++ b/presentation/DineEase-Partner-Presentation.pptx
@@ -9972,11 +9972,12 @@
                 <a:tableStyleId>{5C22544A-7EE6-4342-B048-85BDC9FD1C3A}</a:tableStyleId>
               </a:tblPr>
               <a:tblGrid>
-                <a:gridCol w="2770632"/>
-                <a:gridCol w="2034540"/>
-                <a:gridCol w="2034540"/>
-                <a:gridCol w="2034540"/>
-                <a:gridCol w="2034540"/>
+                <a:gridCol w="2404872"/>
+                <a:gridCol w="1700784"/>
+                <a:gridCol w="1700784"/>
+                <a:gridCol w="1700784"/>
+                <a:gridCol w="1700784"/>
+                <a:gridCol w="1700784"/>
               </a:tblGrid>
               <a:tr h="585216">
                 <a:tc>
@@ -9986,7 +9987,7 @@
                     <a:p>
                       <a:pPr algn="l"/>
                       <a:r>
-                        <a:rPr sz="1300" b="1">
+                        <a:rPr sz="1200" b="1">
                           <a:solidFill>
                             <a:srgbClr val="FFFFFF"/>
                           </a:solidFill>
@@ -10009,7 +10010,7 @@
                     <a:p>
                       <a:pPr algn="ctr"/>
                       <a:r>
-                        <a:rPr sz="1300" b="1">
+                        <a:rPr sz="1200" b="1">
                           <a:solidFill>
                             <a:srgbClr val="0F2D40"/>
                           </a:solidFill>
@@ -10032,7 +10033,30 @@
                     <a:p>
                       <a:pPr algn="ctr"/>
                       <a:r>
-                        <a:rPr sz="1300" b="1">
+                        <a:rPr sz="1200" b="1">
+                          <a:solidFill>
+                            <a:srgbClr val="FFFFFF"/>
+                          </a:solidFill>
+                          <a:latin typeface="Georgia"/>
+                        </a:rPr>
+                        <a:t>Eat App</a:t>
+                      </a:r>
+                    </a:p>
+                  </a:txBody>
+                  <a:tcPr marL="91440" marR="54864" marT="18288" marB="18288" anchor="ctr">
+                    <a:solidFill>
+                      <a:srgbClr val="0F2D40"/>
+                    </a:solidFill>
+                  </a:tcPr>
+                </a:tc>
+                <a:tc>
+                  <a:txBody>
+                    <a:bodyPr wrap="square"/>
+                    <a:lstStyle/>
+                    <a:p>
+                      <a:pPr algn="ctr"/>
+                      <a:r>
+                        <a:rPr sz="1200" b="1">
                           <a:solidFill>
                             <a:srgbClr val="FFFFFF"/>
                           </a:solidFill>
@@ -10055,7 +10079,7 @@
                     <a:p>
                       <a:pPr algn="ctr"/>
                       <a:r>
-                        <a:rPr sz="1300" b="1">
+                        <a:rPr sz="1200" b="1">
                           <a:solidFill>
                             <a:srgbClr val="FFFFFF"/>
                           </a:solidFill>
@@ -10078,7 +10102,7 @@
                     <a:p>
                       <a:pPr algn="ctr"/>
                       <a:r>
-                        <a:rPr sz="1300" b="1">
+                        <a:rPr sz="1200" b="1">
                           <a:solidFill>
                             <a:srgbClr val="FFFFFF"/>
                           </a:solidFill>
@@ -10103,7 +10127,7 @@
                     <a:p>
                       <a:pPr algn="l"/>
                       <a:r>
-                        <a:rPr sz="1250" b="1">
+                        <a:rPr sz="1100" b="1">
                           <a:solidFill>
                             <a:srgbClr val="FFFFFF"/>
                           </a:solidFill>
@@ -10126,7 +10150,7 @@
                     <a:p>
                       <a:pPr algn="ctr"/>
                       <a:r>
-                        <a:rPr sz="1250" b="1">
+                        <a:rPr sz="1100" b="1">
                           <a:solidFill>
                             <a:srgbClr val="0F2D40"/>
                           </a:solidFill>
@@ -10149,7 +10173,30 @@
                     <a:p>
                       <a:pPr algn="ctr"/>
                       <a:r>
-                        <a:rPr sz="1200">
+                        <a:rPr sz="1050">
+                          <a:solidFill>
+                            <a:srgbClr val="B0C4CC"/>
+                          </a:solidFill>
+                          <a:latin typeface="Calibri"/>
+                        </a:rPr>
+                        <a:t>Flat subscription</a:t>
+                      </a:r>
+                    </a:p>
+                  </a:txBody>
+                  <a:tcPr marL="91440" marR="54864" marT="18288" marB="18288" anchor="ctr">
+                    <a:solidFill>
+                      <a:srgbClr val="163A52"/>
+                    </a:solidFill>
+                  </a:tcPr>
+                </a:tc>
+                <a:tc>
+                  <a:txBody>
+                    <a:bodyPr wrap="square"/>
+                    <a:lstStyle/>
+                    <a:p>
+                      <a:pPr algn="ctr"/>
+                      <a:r>
+                        <a:rPr sz="1050">
                           <a:solidFill>
                             <a:srgbClr val="B0C4CC"/>
                           </a:solidFill>
@@ -10172,7 +10219,7 @@
                     <a:p>
                       <a:pPr algn="ctr"/>
                       <a:r>
-                        <a:rPr sz="1200">
+                        <a:rPr sz="1050">
                           <a:solidFill>
                             <a:srgbClr val="B0C4CC"/>
                           </a:solidFill>
@@ -10195,7 +10242,7 @@
                     <a:p>
                       <a:pPr algn="ctr"/>
                       <a:r>
-                        <a:rPr sz="1200">
+                        <a:rPr sz="1050">
                           <a:solidFill>
                             <a:srgbClr val="B0C4CC"/>
                           </a:solidFill>
@@ -10220,7 +10267,7 @@
                     <a:p>
                       <a:pPr algn="l"/>
                       <a:r>
-                        <a:rPr sz="1250" b="1">
+                        <a:rPr sz="1100" b="1">
                           <a:solidFill>
                             <a:srgbClr val="FFFFFF"/>
                           </a:solidFill>
@@ -10243,7 +10290,7 @@
                     <a:p>
                       <a:pPr algn="ctr"/>
                       <a:r>
-                        <a:rPr sz="1250" b="1">
+                        <a:rPr sz="1100" b="1">
                           <a:solidFill>
                             <a:srgbClr val="0F2D40"/>
                           </a:solidFill>
@@ -10266,7 +10313,30 @@
                     <a:p>
                       <a:pPr algn="ctr"/>
                       <a:r>
-                        <a:rPr sz="1200">
+                        <a:rPr sz="1050">
+                          <a:solidFill>
+                            <a:srgbClr val="B0C4CC"/>
+                          </a:solidFill>
+                          <a:latin typeface="Calibri"/>
+                        </a:rPr>
+                        <a:t>None</a:t>
+                      </a:r>
+                    </a:p>
+                  </a:txBody>
+                  <a:tcPr marL="91440" marR="54864" marT="18288" marB="18288" anchor="ctr">
+                    <a:solidFill>
+                      <a:srgbClr val="163A52"/>
+                    </a:solidFill>
+                  </a:tcPr>
+                </a:tc>
+                <a:tc>
+                  <a:txBody>
+                    <a:bodyPr wrap="square"/>
+                    <a:lstStyle/>
+                    <a:p>
+                      <a:pPr algn="ctr"/>
+                      <a:r>
+                        <a:rPr sz="1050">
                           <a:solidFill>
                             <a:srgbClr val="B0C4CC"/>
                           </a:solidFill>
@@ -10289,7 +10359,7 @@
                     <a:p>
                       <a:pPr algn="ctr"/>
                       <a:r>
-                        <a:rPr sz="1200">
+                        <a:rPr sz="1050">
                           <a:solidFill>
                             <a:srgbClr val="B0C4CC"/>
                           </a:solidFill>
@@ -10312,7 +10382,7 @@
                     <a:p>
                       <a:pPr algn="ctr"/>
                       <a:r>
-                        <a:rPr sz="1200">
+                        <a:rPr sz="1050">
                           <a:solidFill>
                             <a:srgbClr val="B0C4CC"/>
                           </a:solidFill>
@@ -10337,7 +10407,7 @@
                     <a:p>
                       <a:pPr algn="l"/>
                       <a:r>
-                        <a:rPr sz="1250" b="1">
+                        <a:rPr sz="1100" b="1">
                           <a:solidFill>
                             <a:srgbClr val="FFFFFF"/>
                           </a:solidFill>
@@ -10360,7 +10430,7 @@
                     <a:p>
                       <a:pPr algn="ctr"/>
                       <a:r>
-                        <a:rPr sz="1250" b="1">
+                        <a:rPr sz="1100" b="1">
                           <a:solidFill>
                             <a:srgbClr val="0F2D40"/>
                           </a:solidFill>
@@ -10383,7 +10453,7 @@
                     <a:p>
                       <a:pPr algn="ctr"/>
                       <a:r>
-                        <a:rPr sz="1200">
+                        <a:rPr sz="1050">
                           <a:solidFill>
                             <a:srgbClr val="B0C4CC"/>
                           </a:solidFill>
@@ -10406,7 +10476,7 @@
                     <a:p>
                       <a:pPr algn="ctr"/>
                       <a:r>
-                        <a:rPr sz="1200">
+                        <a:rPr sz="1050">
                           <a:solidFill>
                             <a:srgbClr val="B0C4CC"/>
                           </a:solidFill>
@@ -10429,7 +10499,30 @@
                     <a:p>
                       <a:pPr algn="ctr"/>
                       <a:r>
-                        <a:rPr sz="1200">
+                        <a:rPr sz="1050">
+                          <a:solidFill>
+                            <a:srgbClr val="B0C4CC"/>
+                          </a:solidFill>
+                          <a:latin typeface="Calibri"/>
+                        </a:rPr>
+                        <a:t>Yes</a:t>
+                      </a:r>
+                    </a:p>
+                  </a:txBody>
+                  <a:tcPr marL="91440" marR="54864" marT="18288" marB="18288" anchor="ctr">
+                    <a:solidFill>
+                      <a:srgbClr val="163A52"/>
+                    </a:solidFill>
+                  </a:tcPr>
+                </a:tc>
+                <a:tc>
+                  <a:txBody>
+                    <a:bodyPr wrap="square"/>
+                    <a:lstStyle/>
+                    <a:p>
+                      <a:pPr algn="ctr"/>
+                      <a:r>
+                        <a:rPr sz="1050">
                           <a:solidFill>
                             <a:srgbClr val="B0C4CC"/>
                           </a:solidFill>
@@ -10454,7 +10547,7 @@
                     <a:p>
                       <a:pPr algn="l"/>
                       <a:r>
-                        <a:rPr sz="1250" b="1">
+                        <a:rPr sz="1100" b="1">
                           <a:solidFill>
                             <a:srgbClr val="FFFFFF"/>
                           </a:solidFill>
@@ -10477,7 +10570,7 @@
                     <a:p>
                       <a:pPr algn="ctr"/>
                       <a:r>
-                        <a:rPr sz="1250" b="1">
+                        <a:rPr sz="1100" b="1">
                           <a:solidFill>
                             <a:srgbClr val="0F2D40"/>
                           </a:solidFill>
@@ -10500,7 +10593,30 @@
                     <a:p>
                       <a:pPr algn="ctr"/>
                       <a:r>
-                        <a:rPr sz="1200">
+                        <a:rPr sz="1050">
+                          <a:solidFill>
+                            <a:srgbClr val="B0C4CC"/>
+                          </a:solidFill>
+                          <a:latin typeface="Calibri"/>
+                        </a:rPr>
+                        <a:t>Limited</a:t>
+                      </a:r>
+                    </a:p>
+                  </a:txBody>
+                  <a:tcPr marL="91440" marR="54864" marT="18288" marB="18288" anchor="ctr">
+                    <a:solidFill>
+                      <a:srgbClr val="163A52"/>
+                    </a:solidFill>
+                  </a:tcPr>
+                </a:tc>
+                <a:tc>
+                  <a:txBody>
+                    <a:bodyPr wrap="square"/>
+                    <a:lstStyle/>
+                    <a:p>
+                      <a:pPr algn="ctr"/>
+                      <a:r>
+                        <a:rPr sz="1050">
                           <a:solidFill>
                             <a:srgbClr val="B0C4CC"/>
                           </a:solidFill>
@@ -10523,7 +10639,7 @@
                     <a:p>
                       <a:pPr algn="ctr"/>
                       <a:r>
-                        <a:rPr sz="1200">
+                        <a:rPr sz="1050">
                           <a:solidFill>
                             <a:srgbClr val="B0C4CC"/>
                           </a:solidFill>
@@ -10546,7 +10662,7 @@
                     <a:p>
                       <a:pPr algn="ctr"/>
                       <a:r>
-                        <a:rPr sz="1200">
+                        <a:rPr sz="1050">
                           <a:solidFill>
                             <a:srgbClr val="B0C4CC"/>
                           </a:solidFill>
@@ -10571,7 +10687,7 @@
                     <a:p>
                       <a:pPr algn="l"/>
                       <a:r>
-                        <a:rPr sz="1250" b="1">
+                        <a:rPr sz="1100" b="1">
                           <a:solidFill>
                             <a:srgbClr val="FFFFFF"/>
                           </a:solidFill>
@@ -10594,7 +10710,7 @@
                     <a:p>
                       <a:pPr algn="ctr"/>
                       <a:r>
-                        <a:rPr sz="1250" b="1">
+                        <a:rPr sz="1100" b="1">
                           <a:solidFill>
                             <a:srgbClr val="0F2D40"/>
                           </a:solidFill>
@@ -10617,7 +10733,7 @@
                     <a:p>
                       <a:pPr algn="ctr"/>
                       <a:r>
-                        <a:rPr sz="1200">
+                        <a:rPr sz="1050">
                           <a:solidFill>
                             <a:srgbClr val="B0C4CC"/>
                           </a:solidFill>
@@ -10640,7 +10756,30 @@
                     <a:p>
                       <a:pPr algn="ctr"/>
                       <a:r>
-                        <a:rPr sz="1200">
+                        <a:rPr sz="1050">
+                          <a:solidFill>
+                            <a:srgbClr val="B0C4CC"/>
+                          </a:solidFill>
+                          <a:latin typeface="Calibri"/>
+                        </a:rPr>
+                        <a:t>No (USD)</a:t>
+                      </a:r>
+                    </a:p>
+                  </a:txBody>
+                  <a:tcPr marL="91440" marR="54864" marT="18288" marB="18288" anchor="ctr">
+                    <a:solidFill>
+                      <a:srgbClr val="163A52"/>
+                    </a:solidFill>
+                  </a:tcPr>
+                </a:tc>
+                <a:tc>
+                  <a:txBody>
+                    <a:bodyPr wrap="square"/>
+                    <a:lstStyle/>
+                    <a:p>
+                      <a:pPr algn="ctr"/>
+                      <a:r>
+                        <a:rPr sz="1050">
                           <a:solidFill>
                             <a:srgbClr val="B0C4CC"/>
                           </a:solidFill>
@@ -10663,7 +10802,7 @@
                     <a:p>
                       <a:pPr algn="ctr"/>
                       <a:r>
-                        <a:rPr sz="1200">
+                        <a:rPr sz="1050">
                           <a:solidFill>
                             <a:srgbClr val="B0C4CC"/>
                           </a:solidFill>
@@ -10688,7 +10827,7 @@
                     <a:p>
                       <a:pPr algn="l"/>
                       <a:r>
-                        <a:rPr sz="1250" b="1">
+                        <a:rPr sz="1100" b="1">
                           <a:solidFill>
                             <a:srgbClr val="FFFFFF"/>
                           </a:solidFill>
@@ -10711,7 +10850,7 @@
                     <a:p>
                       <a:pPr algn="ctr"/>
                       <a:r>
-                        <a:rPr sz="1250" b="1">
+                        <a:rPr sz="1100" b="1">
                           <a:solidFill>
                             <a:srgbClr val="0F2D40"/>
                           </a:solidFill>
@@ -10734,7 +10873,30 @@
                     <a:p>
                       <a:pPr algn="ctr"/>
                       <a:r>
-                        <a:rPr sz="1200">
+                        <a:rPr sz="1050">
+                          <a:solidFill>
+                            <a:srgbClr val="B0C4CC"/>
+                          </a:solidFill>
+                          <a:latin typeface="Calibri"/>
+                        </a:rPr>
+                        <a:t>Stays flat</a:t>
+                      </a:r>
+                    </a:p>
+                  </a:txBody>
+                  <a:tcPr marL="91440" marR="54864" marT="18288" marB="18288" anchor="ctr">
+                    <a:solidFill>
+                      <a:srgbClr val="163A52"/>
+                    </a:solidFill>
+                  </a:tcPr>
+                </a:tc>
+                <a:tc>
+                  <a:txBody>
+                    <a:bodyPr wrap="square"/>
+                    <a:lstStyle/>
+                    <a:p>
+                      <a:pPr algn="ctr"/>
+                      <a:r>
+                        <a:rPr sz="1050">
                           <a:solidFill>
                             <a:srgbClr val="B0C4CC"/>
                           </a:solidFill>
@@ -10757,7 +10919,7 @@
                     <a:p>
                       <a:pPr algn="ctr"/>
                       <a:r>
-                        <a:rPr sz="1200">
+                        <a:rPr sz="1050">
                           <a:solidFill>
                             <a:srgbClr val="B0C4CC"/>
                           </a:solidFill>
@@ -10780,7 +10942,7 @@
                     <a:p>
                       <a:pPr algn="ctr"/>
                       <a:r>
-                        <a:rPr sz="1200">
+                        <a:rPr sz="1050">
                           <a:solidFill>
                             <a:srgbClr val="B0C4CC"/>
                           </a:solidFill>

</xml_diff>

<commit_message>
Add dedicated DineEase vs Eat App slide with real plan data
New slide 9 compares plans side by side using Eat App's live pricing
(Free $0 / Starter $48 / Essential $111 / Pro $209, yearly billing):
- Eat App caps covers on cheaper plans and charges $19-39/mo add-ons
  for waitlist, CRM, messaging and reports even on its recommended tier
- DineEase is priced per location, covers uncapped, all features
  included, EUR with VAT, plus a local consumer app
Renumbered subsequent slides.

Co-Authored-By: Claude Opus 4.8 <noreply@anthropic.com>
Claude-Session: https://claude.ai/code/session_01CyhSA8ZRVEByeRTLp2jTDH
</commit_message>
<xml_diff>
--- a/presentation/DineEase-Partner-Presentation.pptx
+++ b/presentation/DineEase-Partner-Presentation.pptx
@@ -16,6 +16,7 @@
     <p:sldId id="264" r:id="rId15"/>
     <p:sldId id="265" r:id="rId16"/>
     <p:sldId id="266" r:id="rId17"/>
+    <p:sldId id="267" r:id="rId18"/>
   </p:sldIdLst>
   <p:sldSz cx="12191695" cy="6858000" type="screen4x3"/>
   <p:notesSz cx="6858000" cy="9144000"/>
@@ -3430,6 +3431,940 @@
             <a:avLst/>
           </a:prstGeom>
           <a:solidFill>
+            <a:srgbClr val="0F2D40"/>
+          </a:solidFill>
+          <a:ln>
+            <a:noFill/>
+          </a:ln>
+          <a:effectLst/>
+        </p:spPr>
+        <p:style>
+          <a:lnRef idx="1">
+            <a:schemeClr val="accent1"/>
+          </a:lnRef>
+          <a:fillRef idx="3">
+            <a:schemeClr val="accent1"/>
+          </a:fillRef>
+          <a:effectRef idx="2">
+            <a:schemeClr val="accent1"/>
+          </a:effectRef>
+          <a:fontRef idx="minor">
+            <a:schemeClr val="lt1"/>
+          </a:fontRef>
+        </p:style>
+        <p:txBody>
+          <a:bodyPr rtlCol="0" anchor="ctr"/>
+          <a:lstStyle/>
+          <a:p>
+            <a:pPr algn="ctr"/>
+          </a:p>
+        </p:txBody>
+      </p:sp>
+      <p:sp>
+        <p:nvSpPr>
+          <p:cNvPr id="3" name="TextBox 2"/>
+          <p:cNvSpPr txBox="1"/>
+          <p:nvPr/>
+        </p:nvSpPr>
+        <p:spPr>
+          <a:xfrm>
+            <a:off x="822960" y="594360"/>
+            <a:ext cx="7315200" cy="365760"/>
+          </a:xfrm>
+          <a:prstGeom prst="rect">
+            <a:avLst/>
+          </a:prstGeom>
+          <a:noFill/>
+        </p:spPr>
+        <p:txBody>
+          <a:bodyPr wrap="square" lIns="0" rIns="0" tIns="0" bIns="0">
+            <a:spAutoFit/>
+          </a:bodyPr>
+          <a:lstStyle/>
+          <a:p>
+            <a:pPr algn="l">
+              <a:spcBef>
+                <a:spcPts val="0"/>
+              </a:spcBef>
+              <a:spcAft>
+                <a:spcPts val="0"/>
+              </a:spcAft>
+            </a:pPr>
+            <a:r>
+              <a:rPr sz="1300" b="1" i="0">
+                <a:solidFill>
+                  <a:srgbClr val="C8A96E"/>
+                </a:solidFill>
+                <a:latin typeface="Calibri"/>
+              </a:rPr>
+              <a:t>THE COST ADVANTAGE</a:t>
+            </a:r>
+          </a:p>
+        </p:txBody>
+      </p:sp>
+      <p:sp>
+        <p:nvSpPr>
+          <p:cNvPr id="4" name="TextBox 3"/>
+          <p:cNvSpPr txBox="1"/>
+          <p:nvPr/>
+        </p:nvSpPr>
+        <p:spPr>
+          <a:xfrm>
+            <a:off x="822960" y="1051560"/>
+            <a:ext cx="10515600" cy="1097280"/>
+          </a:xfrm>
+          <a:prstGeom prst="rect">
+            <a:avLst/>
+          </a:prstGeom>
+          <a:noFill/>
+        </p:spPr>
+        <p:txBody>
+          <a:bodyPr wrap="square" lIns="0" rIns="0" tIns="0" bIns="0">
+            <a:spAutoFit/>
+          </a:bodyPr>
+          <a:lstStyle/>
+          <a:p>
+            <a:pPr algn="l">
+              <a:spcBef>
+                <a:spcPts val="0"/>
+              </a:spcBef>
+              <a:spcAft>
+                <a:spcPts val="600"/>
+              </a:spcAft>
+            </a:pPr>
+            <a:r>
+              <a:rPr sz="3400" b="1" i="0">
+                <a:solidFill>
+                  <a:srgbClr val="FFFFFF"/>
+                </a:solidFill>
+                <a:latin typeface="Georgia"/>
+              </a:rPr>
+              <a:t>Flat beats commission as you get busy</a:t>
+            </a:r>
+          </a:p>
+        </p:txBody>
+      </p:sp>
+      <p:sp>
+        <p:nvSpPr>
+          <p:cNvPr id="5" name="Rectangle 4"/>
+          <p:cNvSpPr/>
+          <p:nvPr/>
+        </p:nvSpPr>
+        <p:spPr>
+          <a:xfrm>
+            <a:off x="868680" y="1874519"/>
+            <a:ext cx="822960" cy="38100"/>
+          </a:xfrm>
+          <a:prstGeom prst="rect">
+            <a:avLst/>
+          </a:prstGeom>
+          <a:solidFill>
+            <a:srgbClr val="C8A96E"/>
+          </a:solidFill>
+          <a:ln>
+            <a:noFill/>
+          </a:ln>
+          <a:effectLst/>
+        </p:spPr>
+        <p:style>
+          <a:lnRef idx="1">
+            <a:schemeClr val="accent1"/>
+          </a:lnRef>
+          <a:fillRef idx="3">
+            <a:schemeClr val="accent1"/>
+          </a:fillRef>
+          <a:effectRef idx="2">
+            <a:schemeClr val="accent1"/>
+          </a:effectRef>
+          <a:fontRef idx="minor">
+            <a:schemeClr val="lt1"/>
+          </a:fontRef>
+        </p:style>
+        <p:txBody>
+          <a:bodyPr rtlCol="0" anchor="ctr"/>
+          <a:lstStyle/>
+          <a:p>
+            <a:pPr algn="ctr"/>
+          </a:p>
+        </p:txBody>
+      </p:sp>
+      <p:sp>
+        <p:nvSpPr>
+          <p:cNvPr id="6" name="TextBox 5"/>
+          <p:cNvSpPr txBox="1"/>
+          <p:nvPr/>
+        </p:nvSpPr>
+        <p:spPr>
+          <a:xfrm>
+            <a:off x="822960" y="2057400"/>
+            <a:ext cx="10515600" cy="548640"/>
+          </a:xfrm>
+          <a:prstGeom prst="rect">
+            <a:avLst/>
+          </a:prstGeom>
+          <a:noFill/>
+        </p:spPr>
+        <p:txBody>
+          <a:bodyPr wrap="square" lIns="0" rIns="0" tIns="0" bIns="0">
+            <a:spAutoFit/>
+          </a:bodyPr>
+          <a:lstStyle/>
+          <a:p>
+            <a:pPr algn="l">
+              <a:spcBef>
+                <a:spcPts val="0"/>
+              </a:spcBef>
+              <a:spcAft>
+                <a:spcPts val="0"/>
+              </a:spcAft>
+            </a:pPr>
+            <a:r>
+              <a:rPr sz="1600" b="0" i="0">
+                <a:solidFill>
+                  <a:srgbClr val="C8A96E"/>
+                </a:solidFill>
+                <a:latin typeface="Calibri"/>
+              </a:rPr>
+              <a:t>Example: a restaurant seating 1,000 booked covers in a month</a:t>
+            </a:r>
+          </a:p>
+        </p:txBody>
+      </p:sp>
+      <p:sp>
+        <p:nvSpPr>
+          <p:cNvPr id="7" name="Rectangle 6"/>
+          <p:cNvSpPr/>
+          <p:nvPr/>
+        </p:nvSpPr>
+        <p:spPr>
+          <a:xfrm>
+            <a:off x="609447" y="2834640"/>
+            <a:ext cx="3383280" cy="2651760"/>
+          </a:xfrm>
+          <a:prstGeom prst="rect">
+            <a:avLst/>
+          </a:prstGeom>
+          <a:solidFill>
+            <a:srgbClr val="163A52"/>
+          </a:solidFill>
+          <a:ln w="25400">
+            <a:solidFill>
+              <a:srgbClr val="C0392B"/>
+            </a:solidFill>
+          </a:ln>
+          <a:effectLst/>
+        </p:spPr>
+        <p:style>
+          <a:lnRef idx="1">
+            <a:schemeClr val="accent1"/>
+          </a:lnRef>
+          <a:fillRef idx="3">
+            <a:schemeClr val="accent1"/>
+          </a:fillRef>
+          <a:effectRef idx="2">
+            <a:schemeClr val="accent1"/>
+          </a:effectRef>
+          <a:fontRef idx="minor">
+            <a:schemeClr val="lt1"/>
+          </a:fontRef>
+        </p:style>
+        <p:txBody>
+          <a:bodyPr rtlCol="0" anchor="ctr"/>
+          <a:lstStyle/>
+          <a:p>
+            <a:pPr algn="ctr"/>
+          </a:p>
+        </p:txBody>
+      </p:sp>
+      <p:sp>
+        <p:nvSpPr>
+          <p:cNvPr id="8" name="Rectangle 7"/>
+          <p:cNvSpPr/>
+          <p:nvPr/>
+        </p:nvSpPr>
+        <p:spPr>
+          <a:xfrm>
+            <a:off x="609447" y="2834640"/>
+            <a:ext cx="3383280" cy="109728"/>
+          </a:xfrm>
+          <a:prstGeom prst="rect">
+            <a:avLst/>
+          </a:prstGeom>
+          <a:solidFill>
+            <a:srgbClr val="C0392B"/>
+          </a:solidFill>
+          <a:ln>
+            <a:noFill/>
+          </a:ln>
+          <a:effectLst/>
+        </p:spPr>
+        <p:style>
+          <a:lnRef idx="1">
+            <a:schemeClr val="accent1"/>
+          </a:lnRef>
+          <a:fillRef idx="3">
+            <a:schemeClr val="accent1"/>
+          </a:fillRef>
+          <a:effectRef idx="2">
+            <a:schemeClr val="accent1"/>
+          </a:effectRef>
+          <a:fontRef idx="minor">
+            <a:schemeClr val="lt1"/>
+          </a:fontRef>
+        </p:style>
+        <p:txBody>
+          <a:bodyPr rtlCol="0" anchor="ctr"/>
+          <a:lstStyle/>
+          <a:p>
+            <a:pPr algn="ctr"/>
+          </a:p>
+        </p:txBody>
+      </p:sp>
+      <p:sp>
+        <p:nvSpPr>
+          <p:cNvPr id="9" name="TextBox 8"/>
+          <p:cNvSpPr txBox="1"/>
+          <p:nvPr/>
+        </p:nvSpPr>
+        <p:spPr>
+          <a:xfrm>
+            <a:off x="883767" y="3200400"/>
+            <a:ext cx="2834640" cy="2103120"/>
+          </a:xfrm>
+          <a:prstGeom prst="rect">
+            <a:avLst/>
+          </a:prstGeom>
+          <a:noFill/>
+        </p:spPr>
+        <p:txBody>
+          <a:bodyPr wrap="square" lIns="0" rIns="0" tIns="0" bIns="0">
+            <a:spAutoFit/>
+          </a:bodyPr>
+          <a:lstStyle/>
+          <a:p>
+            <a:pPr algn="ctr">
+              <a:spcBef>
+                <a:spcPts val="0"/>
+              </a:spcBef>
+              <a:spcAft>
+                <a:spcPts val="1000"/>
+              </a:spcAft>
+            </a:pPr>
+            <a:r>
+              <a:rPr sz="1600" b="1" i="0">
+                <a:solidFill>
+                  <a:srgbClr val="FFFFFF"/>
+                </a:solidFill>
+                <a:latin typeface="Georgia"/>
+              </a:rPr>
+              <a:t>Commission platform</a:t>
+            </a:r>
+          </a:p>
+          <a:p>
+            <a:pPr algn="ctr">
+              <a:spcBef>
+                <a:spcPts val="0"/>
+              </a:spcBef>
+              <a:spcAft>
+                <a:spcPts val="0"/>
+              </a:spcAft>
+            </a:pPr>
+            <a:r>
+              <a:rPr sz="3600" b="1" i="0">
+                <a:solidFill>
+                  <a:srgbClr val="FFFFFF"/>
+                </a:solidFill>
+                <a:latin typeface="Georgia"/>
+              </a:rPr>
+              <a:t>≈ €2,600</a:t>
+            </a:r>
+          </a:p>
+          <a:p>
+            <a:pPr algn="ctr">
+              <a:spcBef>
+                <a:spcPts val="0"/>
+              </a:spcBef>
+              <a:spcAft>
+                <a:spcPts val="1000"/>
+              </a:spcAft>
+            </a:pPr>
+            <a:r>
+              <a:rPr sz="1300" b="0" i="0">
+                <a:solidFill>
+                  <a:srgbClr val="B0C4CC"/>
+                </a:solidFill>
+                <a:latin typeface="Calibri"/>
+              </a:rPr>
+              <a:t>/month</a:t>
+            </a:r>
+          </a:p>
+          <a:p>
+            <a:pPr algn="ctr">
+              <a:lnSpc>
+                <a:spcPct val="125000"/>
+              </a:lnSpc>
+              <a:spcBef>
+                <a:spcPts val="0"/>
+              </a:spcBef>
+              <a:spcAft>
+                <a:spcPts val="600"/>
+              </a:spcAft>
+            </a:pPr>
+            <a:r>
+              <a:rPr sz="1300" b="0" i="0">
+                <a:solidFill>
+                  <a:srgbClr val="B0C4CC"/>
+                </a:solidFill>
+                <a:latin typeface="Calibri"/>
+              </a:rPr>
+              <a:t>at ~€2.60 per guest, every month — and it climbs as you grow</a:t>
+            </a:r>
+          </a:p>
+        </p:txBody>
+      </p:sp>
+      <p:sp>
+        <p:nvSpPr>
+          <p:cNvPr id="10" name="Rectangle 9"/>
+          <p:cNvSpPr/>
+          <p:nvPr/>
+        </p:nvSpPr>
+        <p:spPr>
+          <a:xfrm>
+            <a:off x="4404207" y="2834640"/>
+            <a:ext cx="3383280" cy="2651760"/>
+          </a:xfrm>
+          <a:prstGeom prst="rect">
+            <a:avLst/>
+          </a:prstGeom>
+          <a:solidFill>
+            <a:srgbClr val="163A52"/>
+          </a:solidFill>
+          <a:ln w="25400">
+            <a:solidFill>
+              <a:srgbClr val="1A5570"/>
+            </a:solidFill>
+          </a:ln>
+          <a:effectLst/>
+        </p:spPr>
+        <p:style>
+          <a:lnRef idx="1">
+            <a:schemeClr val="accent1"/>
+          </a:lnRef>
+          <a:fillRef idx="3">
+            <a:schemeClr val="accent1"/>
+          </a:fillRef>
+          <a:effectRef idx="2">
+            <a:schemeClr val="accent1"/>
+          </a:effectRef>
+          <a:fontRef idx="minor">
+            <a:schemeClr val="lt1"/>
+          </a:fontRef>
+        </p:style>
+        <p:txBody>
+          <a:bodyPr rtlCol="0" anchor="ctr"/>
+          <a:lstStyle/>
+          <a:p>
+            <a:pPr algn="ctr"/>
+          </a:p>
+        </p:txBody>
+      </p:sp>
+      <p:sp>
+        <p:nvSpPr>
+          <p:cNvPr id="11" name="Rectangle 10"/>
+          <p:cNvSpPr/>
+          <p:nvPr/>
+        </p:nvSpPr>
+        <p:spPr>
+          <a:xfrm>
+            <a:off x="4404207" y="2834640"/>
+            <a:ext cx="3383280" cy="109728"/>
+          </a:xfrm>
+          <a:prstGeom prst="rect">
+            <a:avLst/>
+          </a:prstGeom>
+          <a:solidFill>
+            <a:srgbClr val="1A5570"/>
+          </a:solidFill>
+          <a:ln>
+            <a:noFill/>
+          </a:ln>
+          <a:effectLst/>
+        </p:spPr>
+        <p:style>
+          <a:lnRef idx="1">
+            <a:schemeClr val="accent1"/>
+          </a:lnRef>
+          <a:fillRef idx="3">
+            <a:schemeClr val="accent1"/>
+          </a:fillRef>
+          <a:effectRef idx="2">
+            <a:schemeClr val="accent1"/>
+          </a:effectRef>
+          <a:fontRef idx="minor">
+            <a:schemeClr val="lt1"/>
+          </a:fontRef>
+        </p:style>
+        <p:txBody>
+          <a:bodyPr rtlCol="0" anchor="ctr"/>
+          <a:lstStyle/>
+          <a:p>
+            <a:pPr algn="ctr"/>
+          </a:p>
+        </p:txBody>
+      </p:sp>
+      <p:sp>
+        <p:nvSpPr>
+          <p:cNvPr id="12" name="TextBox 11"/>
+          <p:cNvSpPr txBox="1"/>
+          <p:nvPr/>
+        </p:nvSpPr>
+        <p:spPr>
+          <a:xfrm>
+            <a:off x="4678527" y="3200400"/>
+            <a:ext cx="2834640" cy="2103120"/>
+          </a:xfrm>
+          <a:prstGeom prst="rect">
+            <a:avLst/>
+          </a:prstGeom>
+          <a:noFill/>
+        </p:spPr>
+        <p:txBody>
+          <a:bodyPr wrap="square" lIns="0" rIns="0" tIns="0" bIns="0">
+            <a:spAutoFit/>
+          </a:bodyPr>
+          <a:lstStyle/>
+          <a:p>
+            <a:pPr algn="ctr">
+              <a:spcBef>
+                <a:spcPts val="0"/>
+              </a:spcBef>
+              <a:spcAft>
+                <a:spcPts val="1000"/>
+              </a:spcAft>
+            </a:pPr>
+            <a:r>
+              <a:rPr sz="1600" b="1" i="0">
+                <a:solidFill>
+                  <a:srgbClr val="FFFFFF"/>
+                </a:solidFill>
+                <a:latin typeface="Georgia"/>
+              </a:rPr>
+              <a:t>OpenTable-style</a:t>
+            </a:r>
+          </a:p>
+          <a:p>
+            <a:pPr algn="ctr">
+              <a:spcBef>
+                <a:spcPts val="0"/>
+              </a:spcBef>
+              <a:spcAft>
+                <a:spcPts val="0"/>
+              </a:spcAft>
+            </a:pPr>
+            <a:r>
+              <a:rPr sz="3600" b="1" i="0">
+                <a:solidFill>
+                  <a:srgbClr val="FFFFFF"/>
+                </a:solidFill>
+                <a:latin typeface="Georgia"/>
+              </a:rPr>
+              <a:t>€140 + fees</a:t>
+            </a:r>
+          </a:p>
+          <a:p>
+            <a:pPr algn="ctr">
+              <a:spcBef>
+                <a:spcPts val="0"/>
+              </a:spcBef>
+              <a:spcAft>
+                <a:spcPts val="1000"/>
+              </a:spcAft>
+            </a:pPr>
+            <a:r>
+              <a:rPr sz="1300" b="0" i="0">
+                <a:solidFill>
+                  <a:srgbClr val="B0C4CC"/>
+                </a:solidFill>
+                <a:latin typeface="Calibri"/>
+              </a:rPr>
+              <a:t>/month</a:t>
+            </a:r>
+          </a:p>
+          <a:p>
+            <a:pPr algn="ctr">
+              <a:lnSpc>
+                <a:spcPct val="125000"/>
+              </a:lnSpc>
+              <a:spcBef>
+                <a:spcPts val="0"/>
+              </a:spcBef>
+              <a:spcAft>
+                <a:spcPts val="600"/>
+              </a:spcAft>
+            </a:pPr>
+            <a:r>
+              <a:rPr sz="1300" b="0" i="0">
+                <a:solidFill>
+                  <a:srgbClr val="B0C4CC"/>
+                </a:solidFill>
+                <a:latin typeface="Calibri"/>
+              </a:rPr>
+              <a:t>subscription plus $1–1.50 for every network cover</a:t>
+            </a:r>
+          </a:p>
+        </p:txBody>
+      </p:sp>
+      <p:sp>
+        <p:nvSpPr>
+          <p:cNvPr id="13" name="Rectangle 12"/>
+          <p:cNvSpPr/>
+          <p:nvPr/>
+        </p:nvSpPr>
+        <p:spPr>
+          <a:xfrm>
+            <a:off x="8198967" y="2834640"/>
+            <a:ext cx="3383280" cy="2651760"/>
+          </a:xfrm>
+          <a:prstGeom prst="rect">
+            <a:avLst/>
+          </a:prstGeom>
+          <a:solidFill>
+            <a:srgbClr val="163A52"/>
+          </a:solidFill>
+          <a:ln w="25400">
+            <a:solidFill>
+              <a:srgbClr val="2E7D5B"/>
+            </a:solidFill>
+          </a:ln>
+          <a:effectLst/>
+        </p:spPr>
+        <p:style>
+          <a:lnRef idx="1">
+            <a:schemeClr val="accent1"/>
+          </a:lnRef>
+          <a:fillRef idx="3">
+            <a:schemeClr val="accent1"/>
+          </a:fillRef>
+          <a:effectRef idx="2">
+            <a:schemeClr val="accent1"/>
+          </a:effectRef>
+          <a:fontRef idx="minor">
+            <a:schemeClr val="lt1"/>
+          </a:fontRef>
+        </p:style>
+        <p:txBody>
+          <a:bodyPr rtlCol="0" anchor="ctr"/>
+          <a:lstStyle/>
+          <a:p>
+            <a:pPr algn="ctr"/>
+          </a:p>
+        </p:txBody>
+      </p:sp>
+      <p:sp>
+        <p:nvSpPr>
+          <p:cNvPr id="14" name="Rectangle 13"/>
+          <p:cNvSpPr/>
+          <p:nvPr/>
+        </p:nvSpPr>
+        <p:spPr>
+          <a:xfrm>
+            <a:off x="8198967" y="2834640"/>
+            <a:ext cx="3383280" cy="109728"/>
+          </a:xfrm>
+          <a:prstGeom prst="rect">
+            <a:avLst/>
+          </a:prstGeom>
+          <a:solidFill>
+            <a:srgbClr val="2E7D5B"/>
+          </a:solidFill>
+          <a:ln>
+            <a:noFill/>
+          </a:ln>
+          <a:effectLst/>
+        </p:spPr>
+        <p:style>
+          <a:lnRef idx="1">
+            <a:schemeClr val="accent1"/>
+          </a:lnRef>
+          <a:fillRef idx="3">
+            <a:schemeClr val="accent1"/>
+          </a:fillRef>
+          <a:effectRef idx="2">
+            <a:schemeClr val="accent1"/>
+          </a:effectRef>
+          <a:fontRef idx="minor">
+            <a:schemeClr val="lt1"/>
+          </a:fontRef>
+        </p:style>
+        <p:txBody>
+          <a:bodyPr rtlCol="0" anchor="ctr"/>
+          <a:lstStyle/>
+          <a:p>
+            <a:pPr algn="ctr"/>
+          </a:p>
+        </p:txBody>
+      </p:sp>
+      <p:sp>
+        <p:nvSpPr>
+          <p:cNvPr id="15" name="TextBox 14"/>
+          <p:cNvSpPr txBox="1"/>
+          <p:nvPr/>
+        </p:nvSpPr>
+        <p:spPr>
+          <a:xfrm>
+            <a:off x="8473287" y="3200400"/>
+            <a:ext cx="2834640" cy="2103120"/>
+          </a:xfrm>
+          <a:prstGeom prst="rect">
+            <a:avLst/>
+          </a:prstGeom>
+          <a:noFill/>
+        </p:spPr>
+        <p:txBody>
+          <a:bodyPr wrap="square" lIns="0" rIns="0" tIns="0" bIns="0">
+            <a:spAutoFit/>
+          </a:bodyPr>
+          <a:lstStyle/>
+          <a:p>
+            <a:pPr algn="ctr">
+              <a:spcBef>
+                <a:spcPts val="0"/>
+              </a:spcBef>
+              <a:spcAft>
+                <a:spcPts val="1000"/>
+              </a:spcAft>
+            </a:pPr>
+            <a:r>
+              <a:rPr sz="1600" b="1" i="0">
+                <a:solidFill>
+                  <a:srgbClr val="FFFFFF"/>
+                </a:solidFill>
+                <a:latin typeface="Georgia"/>
+              </a:rPr>
+              <a:t>DineEase Duo</a:t>
+            </a:r>
+          </a:p>
+          <a:p>
+            <a:pPr algn="ctr">
+              <a:spcBef>
+                <a:spcPts val="0"/>
+              </a:spcBef>
+              <a:spcAft>
+                <a:spcPts val="0"/>
+              </a:spcAft>
+            </a:pPr>
+            <a:r>
+              <a:rPr sz="3600" b="1" i="0">
+                <a:solidFill>
+                  <a:srgbClr val="C8A96E"/>
+                </a:solidFill>
+                <a:latin typeface="Georgia"/>
+              </a:rPr>
+              <a:t>€104</a:t>
+            </a:r>
+          </a:p>
+          <a:p>
+            <a:pPr algn="ctr">
+              <a:spcBef>
+                <a:spcPts val="0"/>
+              </a:spcBef>
+              <a:spcAft>
+                <a:spcPts val="1000"/>
+              </a:spcAft>
+            </a:pPr>
+            <a:r>
+              <a:rPr sz="1300" b="0" i="0">
+                <a:solidFill>
+                  <a:srgbClr val="B0C4CC"/>
+                </a:solidFill>
+                <a:latin typeface="Calibri"/>
+              </a:rPr>
+              <a:t>/month</a:t>
+            </a:r>
+          </a:p>
+          <a:p>
+            <a:pPr algn="ctr">
+              <a:lnSpc>
+                <a:spcPct val="125000"/>
+              </a:lnSpc>
+              <a:spcBef>
+                <a:spcPts val="0"/>
+              </a:spcBef>
+              <a:spcAft>
+                <a:spcPts val="600"/>
+              </a:spcAft>
+            </a:pPr>
+            <a:r>
+              <a:rPr sz="1300" b="0" i="0">
+                <a:solidFill>
+                  <a:srgbClr val="B0C4CC"/>
+                </a:solidFill>
+                <a:latin typeface="Calibri"/>
+              </a:rPr>
+              <a:t>flat — VAT included, no per-cover fee, no matter how busy</a:t>
+            </a:r>
+          </a:p>
+        </p:txBody>
+      </p:sp>
+      <p:sp>
+        <p:nvSpPr>
+          <p:cNvPr id="16" name="TextBox 15"/>
+          <p:cNvSpPr txBox="1"/>
+          <p:nvPr/>
+        </p:nvSpPr>
+        <p:spPr>
+          <a:xfrm>
+            <a:off x="822960" y="5806440"/>
+            <a:ext cx="10515600" cy="548640"/>
+          </a:xfrm>
+          <a:prstGeom prst="rect">
+            <a:avLst/>
+          </a:prstGeom>
+          <a:noFill/>
+        </p:spPr>
+        <p:txBody>
+          <a:bodyPr wrap="square" lIns="0" rIns="0" tIns="0" bIns="0">
+            <a:spAutoFit/>
+          </a:bodyPr>
+          <a:lstStyle/>
+          <a:p>
+            <a:pPr algn="ctr">
+              <a:spcBef>
+                <a:spcPts val="0"/>
+              </a:spcBef>
+              <a:spcAft>
+                <a:spcPts val="0"/>
+              </a:spcAft>
+            </a:pPr>
+            <a:r>
+              <a:rPr sz="1400" b="0" i="0">
+                <a:solidFill>
+                  <a:srgbClr val="F4F1EC"/>
+                </a:solidFill>
+                <a:latin typeface="Calibri"/>
+              </a:rPr>
+              <a:t>With DineEase your cost is predictable. The more diners we send you, the more you save versus commission models.</a:t>
+            </a:r>
+          </a:p>
+        </p:txBody>
+      </p:sp>
+      <p:sp>
+        <p:nvSpPr>
+          <p:cNvPr id="17" name="TextBox 16"/>
+          <p:cNvSpPr txBox="1"/>
+          <p:nvPr/>
+        </p:nvSpPr>
+        <p:spPr>
+          <a:xfrm>
+            <a:off x="11247120" y="6400800"/>
+            <a:ext cx="731520" cy="365760"/>
+          </a:xfrm>
+          <a:prstGeom prst="rect">
+            <a:avLst/>
+          </a:prstGeom>
+          <a:noFill/>
+        </p:spPr>
+        <p:txBody>
+          <a:bodyPr wrap="square" lIns="0" rIns="0" tIns="0" bIns="0">
+            <a:spAutoFit/>
+          </a:bodyPr>
+          <a:lstStyle/>
+          <a:p>
+            <a:pPr algn="r">
+              <a:spcBef>
+                <a:spcPts val="0"/>
+              </a:spcBef>
+              <a:spcAft>
+                <a:spcPts val="0"/>
+              </a:spcAft>
+            </a:pPr>
+            <a:r>
+              <a:rPr sz="1000" b="0" i="0">
+                <a:solidFill>
+                  <a:srgbClr val="B0C4CC"/>
+                </a:solidFill>
+                <a:latin typeface="Calibri"/>
+              </a:rPr>
+              <a:t>10</a:t>
+            </a:r>
+          </a:p>
+        </p:txBody>
+      </p:sp>
+      <p:sp>
+        <p:nvSpPr>
+          <p:cNvPr id="18" name="TextBox 17"/>
+          <p:cNvSpPr txBox="1"/>
+          <p:nvPr/>
+        </p:nvSpPr>
+        <p:spPr>
+          <a:xfrm>
+            <a:off x="822960" y="6400800"/>
+            <a:ext cx="4572000" cy="365760"/>
+          </a:xfrm>
+          <a:prstGeom prst="rect">
+            <a:avLst/>
+          </a:prstGeom>
+          <a:noFill/>
+        </p:spPr>
+        <p:txBody>
+          <a:bodyPr wrap="square" lIns="0" rIns="0" tIns="0" bIns="0">
+            <a:spAutoFit/>
+          </a:bodyPr>
+          <a:lstStyle/>
+          <a:p>
+            <a:pPr algn="l">
+              <a:spcBef>
+                <a:spcPts val="0"/>
+              </a:spcBef>
+              <a:spcAft>
+                <a:spcPts val="0"/>
+              </a:spcAft>
+            </a:pPr>
+            <a:r>
+              <a:rPr sz="1000" b="0" i="0">
+                <a:solidFill>
+                  <a:srgbClr val="B0C4CC"/>
+                </a:solidFill>
+                <a:latin typeface="Calibri"/>
+              </a:rPr>
+              <a:t>DineEase  ·  Partner Overview</a:t>
+            </a:r>
+          </a:p>
+        </p:txBody>
+      </p:sp>
+    </p:spTree>
+  </p:cSld>
+  <p:clrMapOvr>
+    <a:masterClrMapping/>
+  </p:clrMapOvr>
+</p:sld>
+</file>
+
+<file path=ppt/slides/slide11.xml><?xml version="1.0" encoding="utf-8"?>
+<p:sld xmlns:a="http://schemas.openxmlformats.org/drawingml/2006/main" xmlns:p="http://schemas.openxmlformats.org/presentationml/2006/main" xmlns:r="http://schemas.openxmlformats.org/officeDocument/2006/relationships">
+  <p:cSld>
+    <p:spTree>
+      <p:nvGrpSpPr>
+        <p:cNvPr id="1" name=""/>
+        <p:cNvGrpSpPr/>
+        <p:nvPr/>
+      </p:nvGrpSpPr>
+      <p:grpSpPr/>
+      <p:sp>
+        <p:nvSpPr>
+          <p:cNvPr id="2" name="Rectangle 1"/>
+          <p:cNvSpPr/>
+          <p:nvPr/>
+        </p:nvSpPr>
+        <p:spPr>
+          <a:xfrm>
+            <a:off x="0" y="0"/>
+            <a:ext cx="12191695" cy="6858000"/>
+          </a:xfrm>
+          <a:prstGeom prst="rect">
+            <a:avLst/>
+          </a:prstGeom>
+          <a:solidFill>
             <a:srgbClr val="14435E"/>
           </a:solidFill>
           <a:ln>
@@ -4064,7 +4999,7 @@
                 </a:solidFill>
                 <a:latin typeface="Calibri"/>
               </a:rPr>
-              <a:t>10</a:t>
+              <a:t>11</a:t>
             </a:r>
           </a:p>
         </p:txBody>
@@ -4119,7 +5054,7 @@
 </p:sld>
 </file>
 
-<file path=ppt/slides/slide11.xml><?xml version="1.0" encoding="utf-8"?>
+<file path=ppt/slides/slide12.xml><?xml version="1.0" encoding="utf-8"?>
 <p:sld xmlns:a="http://schemas.openxmlformats.org/drawingml/2006/main" xmlns:p="http://schemas.openxmlformats.org/presentationml/2006/main" xmlns:r="http://schemas.openxmlformats.org/officeDocument/2006/relationships">
   <p:cSld>
     <p:spTree>
@@ -11188,7 +12123,7 @@
                 </a:solidFill>
                 <a:latin typeface="Calibri"/>
               </a:rPr>
-              <a:t>THE COST ADVANTAGE</a:t>
+              <a:t>OUR CLOSEST COMPETITOR</a:t>
             </a:r>
           </a:p>
         </p:txBody>
@@ -11201,8 +12136,8 @@
         </p:nvSpPr>
         <p:spPr>
           <a:xfrm>
-            <a:off x="822960" y="1051560"/>
-            <a:ext cx="10515600" cy="1097280"/>
+            <a:off x="822960" y="960120"/>
+            <a:ext cx="10515600" cy="822960"/>
           </a:xfrm>
           <a:prstGeom prst="rect">
             <a:avLst/>
@@ -11224,36 +12159,80 @@
               </a:spcAft>
             </a:pPr>
             <a:r>
-              <a:rPr sz="3400" b="1" i="0">
+              <a:rPr sz="3000" b="1" i="0">
                 <a:solidFill>
                   <a:srgbClr val="FFFFFF"/>
                 </a:solidFill>
                 <a:latin typeface="Georgia"/>
               </a:rPr>
-              <a:t>Flat beats commission as you get busy</a:t>
-            </a:r>
-          </a:p>
-        </p:txBody>
-      </p:sp>
-      <p:sp>
-        <p:nvSpPr>
-          <p:cNvPr id="5" name="Rectangle 4"/>
+              <a:t>DineEase vs Eat App — same idea, built for Cyprus</a:t>
+            </a:r>
+          </a:p>
+        </p:txBody>
+      </p:sp>
+      <p:sp>
+        <p:nvSpPr>
+          <p:cNvPr id="5" name="TextBox 4"/>
+          <p:cNvSpPr txBox="1"/>
+          <p:nvPr/>
+        </p:nvSpPr>
+        <p:spPr>
+          <a:xfrm>
+            <a:off x="868680" y="1645920"/>
+            <a:ext cx="10515600" cy="457200"/>
+          </a:xfrm>
+          <a:prstGeom prst="rect">
+            <a:avLst/>
+          </a:prstGeom>
+          <a:noFill/>
+        </p:spPr>
+        <p:txBody>
+          <a:bodyPr wrap="square" lIns="0" rIns="0" tIns="0" bIns="0">
+            <a:spAutoFit/>
+          </a:bodyPr>
+          <a:lstStyle/>
+          <a:p>
+            <a:pPr algn="l">
+              <a:spcBef>
+                <a:spcPts val="0"/>
+              </a:spcBef>
+              <a:spcAft>
+                <a:spcPts val="0"/>
+              </a:spcAft>
+            </a:pPr>
+            <a:r>
+              <a:rPr sz="1400" b="0" i="0">
+                <a:solidFill>
+                  <a:srgbClr val="C8A96E"/>
+                </a:solidFill>
+                <a:latin typeface="Calibri"/>
+              </a:rPr>
+              <a:t>Both are flat-fee and commission-free. The difference is how you're priced — and who fills your tables.</a:t>
+            </a:r>
+          </a:p>
+        </p:txBody>
+      </p:sp>
+      <p:sp>
+        <p:nvSpPr>
+          <p:cNvPr id="6" name="Rectangle 5"/>
           <p:cNvSpPr/>
           <p:nvPr/>
         </p:nvSpPr>
         <p:spPr>
           <a:xfrm>
-            <a:off x="868680" y="1874519"/>
-            <a:ext cx="822960" cy="38100"/>
+            <a:off x="640080" y="2240280"/>
+            <a:ext cx="5486400" cy="3154680"/>
           </a:xfrm>
           <a:prstGeom prst="rect">
             <a:avLst/>
           </a:prstGeom>
           <a:solidFill>
-            <a:srgbClr val="C8A96E"/>
+            <a:srgbClr val="14435E"/>
           </a:solidFill>
-          <a:ln>
-            <a:noFill/>
+          <a:ln w="25400">
+            <a:solidFill>
+              <a:srgbClr val="C8A96E"/>
+            </a:solidFill>
           </a:ln>
           <a:effectLst/>
         </p:spPr>
@@ -11281,14 +12260,14 @@
       </p:sp>
       <p:sp>
         <p:nvSpPr>
-          <p:cNvPr id="6" name="TextBox 5"/>
+          <p:cNvPr id="7" name="TextBox 6"/>
           <p:cNvSpPr txBox="1"/>
           <p:nvPr/>
         </p:nvSpPr>
         <p:spPr>
           <a:xfrm>
-            <a:off x="822960" y="2057400"/>
-            <a:ext cx="10515600" cy="548640"/>
+            <a:off x="960120" y="2468880"/>
+            <a:ext cx="4937760" cy="2834640"/>
           </a:xfrm>
           <a:prstGeom prst="rect">
             <a:avLst/>
@@ -11306,31 +12285,217 @@
                 <a:spcPts val="0"/>
               </a:spcBef>
               <a:spcAft>
-                <a:spcPts val="0"/>
-              </a:spcAft>
-            </a:pPr>
-            <a:r>
-              <a:rPr sz="1600" b="0" i="0">
+                <a:spcPts val="200"/>
+              </a:spcAft>
+            </a:pPr>
+            <a:r>
+              <a:rPr sz="1600" b="1" i="0">
                 <a:solidFill>
                   <a:srgbClr val="C8A96E"/>
                 </a:solidFill>
                 <a:latin typeface="Calibri"/>
               </a:rPr>
-              <a:t>Example: a restaurant seating 1,000 booked covers in a month</a:t>
-            </a:r>
-          </a:p>
-        </p:txBody>
-      </p:sp>
-      <p:sp>
-        <p:nvSpPr>
-          <p:cNvPr id="7" name="Rectangle 6"/>
+              <a:t>DINEEASE</a:t>
+            </a:r>
+          </a:p>
+          <a:p>
+            <a:pPr algn="l">
+              <a:spcBef>
+                <a:spcPts val="0"/>
+              </a:spcBef>
+              <a:spcAft>
+                <a:spcPts val="1000"/>
+              </a:spcAft>
+            </a:pPr>
+            <a:r>
+              <a:rPr sz="1250" b="0" i="1">
+                <a:solidFill>
+                  <a:srgbClr val="F4F1EC"/>
+                </a:solidFill>
+                <a:latin typeface="Calibri"/>
+              </a:rPr>
+              <a:t>Priced per location · covers never capped · EUR, VAT incl.</a:t>
+            </a:r>
+          </a:p>
+          <a:p>
+            <a:pPr>
+              <a:lnSpc>
+                <a:spcPct val="100000"/>
+              </a:lnSpc>
+              <a:spcAft>
+                <a:spcPts val="700"/>
+              </a:spcAft>
+            </a:pPr>
+            <a:r>
+              <a:rPr sz="1500" b="1">
+                <a:solidFill>
+                  <a:srgbClr val="FFFFFF"/>
+                </a:solidFill>
+                <a:latin typeface="Calibri"/>
+              </a:rPr>
+              <a:t>Essentials  </a:t>
+            </a:r>
+            <a:r>
+              <a:rPr sz="1500" b="1">
+                <a:solidFill>
+                  <a:srgbClr val="C8A96E"/>
+                </a:solidFill>
+                <a:latin typeface="Georgia"/>
+              </a:rPr>
+              <a:t>€60/mo</a:t>
+            </a:r>
+            <a:r>
+              <a:rPr sz="1250">
+                <a:solidFill>
+                  <a:srgbClr val="B0C4CC"/>
+                </a:solidFill>
+                <a:latin typeface="Calibri"/>
+              </a:rPr>
+              <a:t>   ·  1 location</a:t>
+            </a:r>
+          </a:p>
+          <a:p>
+            <a:pPr>
+              <a:lnSpc>
+                <a:spcPct val="100000"/>
+              </a:lnSpc>
+              <a:spcAft>
+                <a:spcPts val="700"/>
+              </a:spcAft>
+            </a:pPr>
+            <a:r>
+              <a:rPr sz="1500" b="1">
+                <a:solidFill>
+                  <a:srgbClr val="FFFFFF"/>
+                </a:solidFill>
+                <a:latin typeface="Calibri"/>
+              </a:rPr>
+              <a:t>Duo  </a:t>
+            </a:r>
+            <a:r>
+              <a:rPr sz="1500" b="1">
+                <a:solidFill>
+                  <a:srgbClr val="C8A96E"/>
+                </a:solidFill>
+                <a:latin typeface="Georgia"/>
+              </a:rPr>
+              <a:t>€104/mo</a:t>
+            </a:r>
+            <a:r>
+              <a:rPr sz="1250">
+                <a:solidFill>
+                  <a:srgbClr val="B0C4CC"/>
+                </a:solidFill>
+                <a:latin typeface="Calibri"/>
+              </a:rPr>
+              <a:t>   ·  up to 2 locations</a:t>
+            </a:r>
+          </a:p>
+          <a:p>
+            <a:pPr>
+              <a:lnSpc>
+                <a:spcPct val="100000"/>
+              </a:lnSpc>
+              <a:spcAft>
+                <a:spcPts val="700"/>
+              </a:spcAft>
+            </a:pPr>
+            <a:r>
+              <a:rPr sz="1500" b="1">
+                <a:solidFill>
+                  <a:srgbClr val="FFFFFF"/>
+                </a:solidFill>
+                <a:latin typeface="Calibri"/>
+              </a:rPr>
+              <a:t>Group  </a:t>
+            </a:r>
+            <a:r>
+              <a:rPr sz="1500" b="1">
+                <a:solidFill>
+                  <a:srgbClr val="C8A96E"/>
+                </a:solidFill>
+                <a:latin typeface="Georgia"/>
+              </a:rPr>
+              <a:t>€144/mo</a:t>
+            </a:r>
+            <a:r>
+              <a:rPr sz="1250">
+                <a:solidFill>
+                  <a:srgbClr val="B0C4CC"/>
+                </a:solidFill>
+                <a:latin typeface="Calibri"/>
+              </a:rPr>
+              <a:t>   ·  up to 3 locations</a:t>
+            </a:r>
+          </a:p>
+          <a:p>
+            <a:pPr>
+              <a:lnSpc>
+                <a:spcPct val="100000"/>
+              </a:lnSpc>
+              <a:spcAft>
+                <a:spcPts val="700"/>
+              </a:spcAft>
+            </a:pPr>
+            <a:r>
+              <a:rPr sz="1500" b="1">
+                <a:solidFill>
+                  <a:srgbClr val="FFFFFF"/>
+                </a:solidFill>
+                <a:latin typeface="Calibri"/>
+              </a:rPr>
+              <a:t>Portfolio  </a:t>
+            </a:r>
+            <a:r>
+              <a:rPr sz="1500" b="1">
+                <a:solidFill>
+                  <a:srgbClr val="C8A96E"/>
+                </a:solidFill>
+                <a:latin typeface="Georgia"/>
+              </a:rPr>
+              <a:t>€200/mo</a:t>
+            </a:r>
+            <a:r>
+              <a:rPr sz="1250">
+                <a:solidFill>
+                  <a:srgbClr val="B0C4CC"/>
+                </a:solidFill>
+                <a:latin typeface="Calibri"/>
+              </a:rPr>
+              <a:t>   ·  4–5 locations</a:t>
+            </a:r>
+          </a:p>
+          <a:p>
+            <a:pPr algn="l">
+              <a:spcBef>
+                <a:spcPts val="400"/>
+              </a:spcBef>
+              <a:spcAft>
+                <a:spcPts val="0"/>
+              </a:spcAft>
+            </a:pPr>
+            <a:r>
+              <a:rPr sz="1250" b="0" i="0">
+                <a:solidFill>
+                  <a:srgbClr val="C8A96E"/>
+                </a:solidFill>
+                <a:latin typeface="Calibri"/>
+              </a:rPr>
+              <a:t>+ your venue in the DineEase consumer app for Cyprus diners</a:t>
+            </a:r>
+          </a:p>
+        </p:txBody>
+      </p:sp>
+      <p:sp>
+        <p:nvSpPr>
+          <p:cNvPr id="8" name="Rectangle 7"/>
           <p:cNvSpPr/>
           <p:nvPr/>
         </p:nvSpPr>
         <p:spPr>
           <a:xfrm>
-            <a:off x="609447" y="2834640"/>
-            <a:ext cx="3383280" cy="2651760"/>
+            <a:off x="6355080" y="2240280"/>
+            <a:ext cx="5212080" cy="3154680"/>
           </a:xfrm>
           <a:prstGeom prst="rect">
             <a:avLst/>
@@ -11338,9 +12503,9 @@
           <a:solidFill>
             <a:srgbClr val="163A52"/>
           </a:solidFill>
-          <a:ln w="25400">
+          <a:ln w="12700">
             <a:solidFill>
-              <a:srgbClr val="C0392B"/>
+              <a:srgbClr val="1A5570"/>
             </a:solidFill>
           </a:ln>
           <a:effectLst/>
@@ -11369,58 +12534,14 @@
       </p:sp>
       <p:sp>
         <p:nvSpPr>
-          <p:cNvPr id="8" name="Rectangle 7"/>
-          <p:cNvSpPr/>
-          <p:nvPr/>
-        </p:nvSpPr>
-        <p:spPr>
-          <a:xfrm>
-            <a:off x="609447" y="2834640"/>
-            <a:ext cx="3383280" cy="109728"/>
-          </a:xfrm>
-          <a:prstGeom prst="rect">
-            <a:avLst/>
-          </a:prstGeom>
-          <a:solidFill>
-            <a:srgbClr val="C0392B"/>
-          </a:solidFill>
-          <a:ln>
-            <a:noFill/>
-          </a:ln>
-          <a:effectLst/>
-        </p:spPr>
-        <p:style>
-          <a:lnRef idx="1">
-            <a:schemeClr val="accent1"/>
-          </a:lnRef>
-          <a:fillRef idx="3">
-            <a:schemeClr val="accent1"/>
-          </a:fillRef>
-          <a:effectRef idx="2">
-            <a:schemeClr val="accent1"/>
-          </a:effectRef>
-          <a:fontRef idx="minor">
-            <a:schemeClr val="lt1"/>
-          </a:fontRef>
-        </p:style>
-        <p:txBody>
-          <a:bodyPr rtlCol="0" anchor="ctr"/>
-          <a:lstStyle/>
-          <a:p>
-            <a:pPr algn="ctr"/>
-          </a:p>
-        </p:txBody>
-      </p:sp>
-      <p:sp>
-        <p:nvSpPr>
           <p:cNvPr id="9" name="TextBox 8"/>
           <p:cNvSpPr txBox="1"/>
           <p:nvPr/>
         </p:nvSpPr>
         <p:spPr>
           <a:xfrm>
-            <a:off x="883767" y="3200400"/>
-            <a:ext cx="2834640" cy="2103120"/>
+            <a:off x="6675120" y="2468880"/>
+            <a:ext cx="4663440" cy="2834640"/>
           </a:xfrm>
           <a:prstGeom prst="rect">
             <a:avLst/>
@@ -11433,7 +12554,26 @@
           </a:bodyPr>
           <a:lstStyle/>
           <a:p>
-            <a:pPr algn="ctr">
+            <a:pPr algn="l">
+              <a:spcBef>
+                <a:spcPts val="0"/>
+              </a:spcBef>
+              <a:spcAft>
+                <a:spcPts val="200"/>
+              </a:spcAft>
+            </a:pPr>
+            <a:r>
+              <a:rPr sz="1600" b="1" i="0">
+                <a:solidFill>
+                  <a:srgbClr val="B0C4CC"/>
+                </a:solidFill>
+                <a:latin typeface="Calibri"/>
+              </a:rPr>
+              <a:t>EAT APP</a:t>
+            </a:r>
+          </a:p>
+          <a:p>
+            <a:pPr algn="l">
               <a:spcBef>
                 <a:spcPts val="0"/>
               </a:spcBef>
@@ -11442,177 +12582,194 @@
               </a:spcAft>
             </a:pPr>
             <a:r>
-              <a:rPr sz="1600" b="1" i="0">
+              <a:rPr sz="1250" b="0" i="1">
+                <a:solidFill>
+                  <a:srgbClr val="B0C4CC"/>
+                </a:solidFill>
+                <a:latin typeface="Calibri"/>
+              </a:rPr>
+              <a:t>Priced by covers &amp; add-ons · USD · no local diner audience</a:t>
+            </a:r>
+          </a:p>
+          <a:p>
+            <a:pPr>
+              <a:lnSpc>
+                <a:spcPct val="100000"/>
+              </a:lnSpc>
+              <a:spcAft>
+                <a:spcPts val="700"/>
+              </a:spcAft>
+            </a:pPr>
+            <a:r>
+              <a:rPr sz="1500" b="1">
                 <a:solidFill>
                   <a:srgbClr val="FFFFFF"/>
                 </a:solidFill>
+                <a:latin typeface="Calibri"/>
+              </a:rPr>
+              <a:t>Free  </a:t>
+            </a:r>
+            <a:r>
+              <a:rPr sz="1500" b="1">
+                <a:solidFill>
+                  <a:srgbClr val="F4F1EC"/>
+                </a:solidFill>
                 <a:latin typeface="Georgia"/>
               </a:rPr>
-              <a:t>Commission platform</a:t>
-            </a:r>
-          </a:p>
-          <a:p>
-            <a:pPr algn="ctr">
-              <a:spcBef>
-                <a:spcPts val="0"/>
-              </a:spcBef>
-              <a:spcAft>
-                <a:spcPts val="0"/>
-              </a:spcAft>
-            </a:pPr>
-            <a:r>
-              <a:rPr sz="3600" b="1" i="0">
+              <a:t>$0/mo</a:t>
+            </a:r>
+            <a:r>
+              <a:rPr sz="1250">
+                <a:solidFill>
+                  <a:srgbClr val="B0C4CC"/>
+                </a:solidFill>
+                <a:latin typeface="Calibri"/>
+              </a:rPr>
+              <a:t>   ·  up to 100 covers/mo</a:t>
+            </a:r>
+          </a:p>
+          <a:p>
+            <a:pPr>
+              <a:lnSpc>
+                <a:spcPct val="100000"/>
+              </a:lnSpc>
+              <a:spcAft>
+                <a:spcPts val="700"/>
+              </a:spcAft>
+            </a:pPr>
+            <a:r>
+              <a:rPr sz="1500" b="1">
                 <a:solidFill>
                   <a:srgbClr val="FFFFFF"/>
                 </a:solidFill>
+                <a:latin typeface="Calibri"/>
+              </a:rPr>
+              <a:t>Starter  </a:t>
+            </a:r>
+            <a:r>
+              <a:rPr sz="1500" b="1">
+                <a:solidFill>
+                  <a:srgbClr val="F4F1EC"/>
+                </a:solidFill>
                 <a:latin typeface="Georgia"/>
               </a:rPr>
-              <a:t>≈ €2,600</a:t>
-            </a:r>
-          </a:p>
-          <a:p>
-            <a:pPr algn="ctr">
-              <a:spcBef>
-                <a:spcPts val="0"/>
-              </a:spcBef>
-              <a:spcAft>
-                <a:spcPts val="1000"/>
-              </a:spcAft>
-            </a:pPr>
-            <a:r>
-              <a:rPr sz="1300" b="0" i="0">
+              <a:t>$48/mo</a:t>
+            </a:r>
+            <a:r>
+              <a:rPr sz="1250">
                 <a:solidFill>
                   <a:srgbClr val="B0C4CC"/>
                 </a:solidFill>
                 <a:latin typeface="Calibri"/>
               </a:rPr>
-              <a:t>/month</a:t>
-            </a:r>
-          </a:p>
-          <a:p>
-            <a:pPr algn="ctr">
+              <a:t>   ·  up to 300 covers/mo</a:t>
+            </a:r>
+          </a:p>
+          <a:p>
+            <a:pPr>
               <a:lnSpc>
-                <a:spcPct val="125000"/>
+                <a:spcPct val="100000"/>
               </a:lnSpc>
-              <a:spcBef>
-                <a:spcPts val="0"/>
-              </a:spcBef>
-              <a:spcAft>
-                <a:spcPts val="600"/>
-              </a:spcAft>
-            </a:pPr>
-            <a:r>
-              <a:rPr sz="1300" b="0" i="0">
+              <a:spcAft>
+                <a:spcPts val="700"/>
+              </a:spcAft>
+            </a:pPr>
+            <a:r>
+              <a:rPr sz="1500" b="1">
+                <a:solidFill>
+                  <a:srgbClr val="FFFFFF"/>
+                </a:solidFill>
+                <a:latin typeface="Calibri"/>
+              </a:rPr>
+              <a:t>Essential  </a:t>
+            </a:r>
+            <a:r>
+              <a:rPr sz="1500" b="1">
+                <a:solidFill>
+                  <a:srgbClr val="F4F1EC"/>
+                </a:solidFill>
+                <a:latin typeface="Georgia"/>
+              </a:rPr>
+              <a:t>$111/mo</a:t>
+            </a:r>
+            <a:r>
+              <a:rPr sz="1250">
                 <a:solidFill>
                   <a:srgbClr val="B0C4CC"/>
                 </a:solidFill>
                 <a:latin typeface="Calibri"/>
               </a:rPr>
-              <a:t>at ~€2.60 per guest, every month — and it climbs as you grow</a:t>
-            </a:r>
-          </a:p>
-        </p:txBody>
-      </p:sp>
-      <p:sp>
-        <p:nvSpPr>
-          <p:cNvPr id="10" name="Rectangle 9"/>
-          <p:cNvSpPr/>
-          <p:nvPr/>
-        </p:nvSpPr>
-        <p:spPr>
-          <a:xfrm>
-            <a:off x="4404207" y="2834640"/>
-            <a:ext cx="3383280" cy="2651760"/>
-          </a:xfrm>
-          <a:prstGeom prst="rect">
-            <a:avLst/>
-          </a:prstGeom>
-          <a:solidFill>
-            <a:srgbClr val="163A52"/>
-          </a:solidFill>
-          <a:ln w="25400">
-            <a:solidFill>
-              <a:srgbClr val="1A5570"/>
-            </a:solidFill>
-          </a:ln>
-          <a:effectLst/>
-        </p:spPr>
-        <p:style>
-          <a:lnRef idx="1">
-            <a:schemeClr val="accent1"/>
-          </a:lnRef>
-          <a:fillRef idx="3">
-            <a:schemeClr val="accent1"/>
-          </a:fillRef>
-          <a:effectRef idx="2">
-            <a:schemeClr val="accent1"/>
-          </a:effectRef>
-          <a:fontRef idx="minor">
-            <a:schemeClr val="lt1"/>
-          </a:fontRef>
-        </p:style>
-        <p:txBody>
-          <a:bodyPr rtlCol="0" anchor="ctr"/>
-          <a:lstStyle/>
-          <a:p>
-            <a:pPr algn="ctr"/>
-          </a:p>
-        </p:txBody>
-      </p:sp>
-      <p:sp>
-        <p:nvSpPr>
-          <p:cNvPr id="11" name="Rectangle 10"/>
-          <p:cNvSpPr/>
-          <p:nvPr/>
-        </p:nvSpPr>
-        <p:spPr>
-          <a:xfrm>
-            <a:off x="4404207" y="2834640"/>
-            <a:ext cx="3383280" cy="109728"/>
-          </a:xfrm>
-          <a:prstGeom prst="rect">
-            <a:avLst/>
-          </a:prstGeom>
-          <a:solidFill>
-            <a:srgbClr val="1A5570"/>
-          </a:solidFill>
-          <a:ln>
-            <a:noFill/>
-          </a:ln>
-          <a:effectLst/>
-        </p:spPr>
-        <p:style>
-          <a:lnRef idx="1">
-            <a:schemeClr val="accent1"/>
-          </a:lnRef>
-          <a:fillRef idx="3">
-            <a:schemeClr val="accent1"/>
-          </a:fillRef>
-          <a:effectRef idx="2">
-            <a:schemeClr val="accent1"/>
-          </a:effectRef>
-          <a:fontRef idx="minor">
-            <a:schemeClr val="lt1"/>
-          </a:fontRef>
-        </p:style>
-        <p:txBody>
-          <a:bodyPr rtlCol="0" anchor="ctr"/>
-          <a:lstStyle/>
-          <a:p>
-            <a:pPr algn="ctr"/>
-          </a:p>
-        </p:txBody>
-      </p:sp>
-      <p:sp>
-        <p:nvSpPr>
-          <p:cNvPr id="12" name="TextBox 11"/>
+              <a:t>   ·  unlimited covers</a:t>
+            </a:r>
+          </a:p>
+          <a:p>
+            <a:pPr>
+              <a:lnSpc>
+                <a:spcPct val="100000"/>
+              </a:lnSpc>
+              <a:spcAft>
+                <a:spcPts val="700"/>
+              </a:spcAft>
+            </a:pPr>
+            <a:r>
+              <a:rPr sz="1500" b="1">
+                <a:solidFill>
+                  <a:srgbClr val="FFFFFF"/>
+                </a:solidFill>
+                <a:latin typeface="Calibri"/>
+              </a:rPr>
+              <a:t>Pro  </a:t>
+            </a:r>
+            <a:r>
+              <a:rPr sz="1500" b="1">
+                <a:solidFill>
+                  <a:srgbClr val="F4F1EC"/>
+                </a:solidFill>
+                <a:latin typeface="Georgia"/>
+              </a:rPr>
+              <a:t>$209/mo</a:t>
+            </a:r>
+            <a:r>
+              <a:rPr sz="1250">
+                <a:solidFill>
+                  <a:srgbClr val="B0C4CC"/>
+                </a:solidFill>
+                <a:latin typeface="Calibri"/>
+              </a:rPr>
+              <a:t>   ·  unlimited covers</a:t>
+            </a:r>
+          </a:p>
+          <a:p>
+            <a:pPr algn="l">
+              <a:spcBef>
+                <a:spcPts val="400"/>
+              </a:spcBef>
+              <a:spcAft>
+                <a:spcPts val="0"/>
+              </a:spcAft>
+            </a:pPr>
+            <a:r>
+              <a:rPr sz="1250" b="0" i="0">
+                <a:solidFill>
+                  <a:srgbClr val="B0C4CC"/>
+                </a:solidFill>
+                <a:latin typeface="Calibri"/>
+              </a:rPr>
+              <a:t>Reservation software only — you fill the tables yourself</a:t>
+            </a:r>
+          </a:p>
+        </p:txBody>
+      </p:sp>
+      <p:sp>
+        <p:nvSpPr>
+          <p:cNvPr id="10" name="TextBox 9"/>
           <p:cNvSpPr txBox="1"/>
           <p:nvPr/>
         </p:nvSpPr>
         <p:spPr>
           <a:xfrm>
-            <a:off x="4678527" y="3200400"/>
-            <a:ext cx="2834640" cy="2103120"/>
+            <a:off x="640080" y="5532120"/>
+            <a:ext cx="10927080" cy="868680"/>
           </a:xfrm>
           <a:prstGeom prst="rect">
             <a:avLst/>
@@ -11626,185 +12783,38 @@
           <a:lstStyle/>
           <a:p>
             <a:pPr algn="ctr">
-              <a:spcBef>
-                <a:spcPts val="0"/>
-              </a:spcBef>
-              <a:spcAft>
-                <a:spcPts val="1000"/>
-              </a:spcAft>
-            </a:pPr>
-            <a:r>
-              <a:rPr sz="1600" b="1" i="0">
-                <a:solidFill>
-                  <a:srgbClr val="FFFFFF"/>
-                </a:solidFill>
-                <a:latin typeface="Georgia"/>
-              </a:rPr>
-              <a:t>OpenTable-style</a:t>
-            </a:r>
-          </a:p>
-          <a:p>
-            <a:pPr algn="ctr">
-              <a:spcBef>
-                <a:spcPts val="0"/>
-              </a:spcBef>
-              <a:spcAft>
-                <a:spcPts val="0"/>
-              </a:spcAft>
-            </a:pPr>
-            <a:r>
-              <a:rPr sz="3600" b="1" i="0">
-                <a:solidFill>
-                  <a:srgbClr val="FFFFFF"/>
-                </a:solidFill>
-                <a:latin typeface="Georgia"/>
-              </a:rPr>
-              <a:t>€140 + fees</a:t>
-            </a:r>
-          </a:p>
-          <a:p>
-            <a:pPr algn="ctr">
-              <a:spcBef>
-                <a:spcPts val="0"/>
-              </a:spcBef>
-              <a:spcAft>
-                <a:spcPts val="1000"/>
+              <a:lnSpc>
+                <a:spcPct val="120000"/>
+              </a:lnSpc>
+              <a:spcBef>
+                <a:spcPts val="0"/>
+              </a:spcBef>
+              <a:spcAft>
+                <a:spcPts val="0"/>
               </a:spcAft>
             </a:pPr>
             <a:r>
               <a:rPr sz="1300" b="0" i="0">
                 <a:solidFill>
-                  <a:srgbClr val="B0C4CC"/>
-                </a:solidFill>
-                <a:latin typeface="Calibri"/>
-              </a:rPr>
-              <a:t>/month</a:t>
-            </a:r>
-          </a:p>
-          <a:p>
-            <a:pPr algn="ctr">
-              <a:lnSpc>
-                <a:spcPct val="125000"/>
-              </a:lnSpc>
-              <a:spcBef>
-                <a:spcPts val="0"/>
-              </a:spcBef>
-              <a:spcAft>
-                <a:spcPts val="600"/>
-              </a:spcAft>
-            </a:pPr>
-            <a:r>
-              <a:rPr sz="1300" b="0" i="0">
-                <a:solidFill>
-                  <a:srgbClr val="B0C4CC"/>
-                </a:solidFill>
-                <a:latin typeface="Calibri"/>
-              </a:rPr>
-              <a:t>subscription plus $1–1.50 for every network cover</a:t>
-            </a:r>
-          </a:p>
-        </p:txBody>
-      </p:sp>
-      <p:sp>
-        <p:nvSpPr>
-          <p:cNvPr id="13" name="Rectangle 12"/>
-          <p:cNvSpPr/>
-          <p:nvPr/>
-        </p:nvSpPr>
-        <p:spPr>
-          <a:xfrm>
-            <a:off x="8198967" y="2834640"/>
-            <a:ext cx="3383280" cy="2651760"/>
-          </a:xfrm>
-          <a:prstGeom prst="rect">
-            <a:avLst/>
-          </a:prstGeom>
-          <a:solidFill>
-            <a:srgbClr val="163A52"/>
-          </a:solidFill>
-          <a:ln w="25400">
-            <a:solidFill>
-              <a:srgbClr val="2E7D5B"/>
-            </a:solidFill>
-          </a:ln>
-          <a:effectLst/>
-        </p:spPr>
-        <p:style>
-          <a:lnRef idx="1">
-            <a:schemeClr val="accent1"/>
-          </a:lnRef>
-          <a:fillRef idx="3">
-            <a:schemeClr val="accent1"/>
-          </a:fillRef>
-          <a:effectRef idx="2">
-            <a:schemeClr val="accent1"/>
-          </a:effectRef>
-          <a:fontRef idx="minor">
-            <a:schemeClr val="lt1"/>
-          </a:fontRef>
-        </p:style>
-        <p:txBody>
-          <a:bodyPr rtlCol="0" anchor="ctr"/>
-          <a:lstStyle/>
-          <a:p>
-            <a:pPr algn="ctr"/>
-          </a:p>
-        </p:txBody>
-      </p:sp>
-      <p:sp>
-        <p:nvSpPr>
-          <p:cNvPr id="14" name="Rectangle 13"/>
-          <p:cNvSpPr/>
-          <p:nvPr/>
-        </p:nvSpPr>
-        <p:spPr>
-          <a:xfrm>
-            <a:off x="8198967" y="2834640"/>
-            <a:ext cx="3383280" cy="109728"/>
-          </a:xfrm>
-          <a:prstGeom prst="rect">
-            <a:avLst/>
-          </a:prstGeom>
-          <a:solidFill>
-            <a:srgbClr val="2E7D5B"/>
-          </a:solidFill>
-          <a:ln>
-            <a:noFill/>
-          </a:ln>
-          <a:effectLst/>
-        </p:spPr>
-        <p:style>
-          <a:lnRef idx="1">
-            <a:schemeClr val="accent1"/>
-          </a:lnRef>
-          <a:fillRef idx="3">
-            <a:schemeClr val="accent1"/>
-          </a:fillRef>
-          <a:effectRef idx="2">
-            <a:schemeClr val="accent1"/>
-          </a:effectRef>
-          <a:fontRef idx="minor">
-            <a:schemeClr val="lt1"/>
-          </a:fontRef>
-        </p:style>
-        <p:txBody>
-          <a:bodyPr rtlCol="0" anchor="ctr"/>
-          <a:lstStyle/>
-          <a:p>
-            <a:pPr algn="ctr"/>
-          </a:p>
-        </p:txBody>
-      </p:sp>
-      <p:sp>
-        <p:nvSpPr>
-          <p:cNvPr id="15" name="TextBox 14"/>
+                  <a:srgbClr val="F4F1EC"/>
+                </a:solidFill>
+                <a:latin typeface="Calibri"/>
+              </a:rPr>
+              <a:t>Takeaway:  Eat App caps covers on cheaper plans, prices in USD, and bills $19–$39/mo add-ons for waitlist, CRM &amp; reports — even on its recommended plan. DineEase includes every feature in each tier, priced per location in EUR (VAT incl.), and sends Cyprus diners your way.</a:t>
+            </a:r>
+          </a:p>
+        </p:txBody>
+      </p:sp>
+      <p:sp>
+        <p:nvSpPr>
+          <p:cNvPr id="11" name="TextBox 10"/>
           <p:cNvSpPr txBox="1"/>
           <p:nvPr/>
         </p:nvSpPr>
         <p:spPr>
           <a:xfrm>
-            <a:off x="8473287" y="3200400"/>
-            <a:ext cx="2834640" cy="2103120"/>
+            <a:off x="640080" y="6419088"/>
+            <a:ext cx="10927080" cy="320040"/>
           </a:xfrm>
           <a:prstGeom prst="rect">
             <a:avLst/>
@@ -11822,91 +12832,31 @@
                 <a:spcPts val="0"/>
               </a:spcBef>
               <a:spcAft>
-                <a:spcPts val="1000"/>
-              </a:spcAft>
-            </a:pPr>
-            <a:r>
-              <a:rPr sz="1600" b="1" i="0">
-                <a:solidFill>
-                  <a:srgbClr val="FFFFFF"/>
-                </a:solidFill>
-                <a:latin typeface="Georgia"/>
-              </a:rPr>
-              <a:t>DineEase Duo</a:t>
-            </a:r>
-          </a:p>
-          <a:p>
-            <a:pPr algn="ctr">
-              <a:spcBef>
-                <a:spcPts val="0"/>
-              </a:spcBef>
-              <a:spcAft>
-                <a:spcPts val="0"/>
-              </a:spcAft>
-            </a:pPr>
-            <a:r>
-              <a:rPr sz="3600" b="1" i="0">
-                <a:solidFill>
-                  <a:srgbClr val="C8A96E"/>
-                </a:solidFill>
-                <a:latin typeface="Georgia"/>
-              </a:rPr>
-              <a:t>€104</a:t>
-            </a:r>
-          </a:p>
-          <a:p>
-            <a:pPr algn="ctr">
-              <a:spcBef>
-                <a:spcPts val="0"/>
-              </a:spcBef>
-              <a:spcAft>
-                <a:spcPts val="1000"/>
-              </a:spcAft>
-            </a:pPr>
-            <a:r>
-              <a:rPr sz="1300" b="0" i="0">
+                <a:spcPts val="0"/>
+              </a:spcAft>
+            </a:pPr>
+            <a:r>
+              <a:rPr sz="950" b="0" i="1">
                 <a:solidFill>
                   <a:srgbClr val="B0C4CC"/>
                 </a:solidFill>
                 <a:latin typeface="Calibri"/>
               </a:rPr>
-              <a:t>/month</a:t>
-            </a:r>
-          </a:p>
-          <a:p>
-            <a:pPr algn="ctr">
-              <a:lnSpc>
-                <a:spcPct val="125000"/>
-              </a:lnSpc>
-              <a:spcBef>
-                <a:spcPts val="0"/>
-              </a:spcBef>
-              <a:spcAft>
-                <a:spcPts val="600"/>
-              </a:spcAft>
-            </a:pPr>
-            <a:r>
-              <a:rPr sz="1300" b="0" i="0">
-                <a:solidFill>
-                  <a:srgbClr val="B0C4CC"/>
-                </a:solidFill>
-                <a:latin typeface="Calibri"/>
-              </a:rPr>
-              <a:t>flat — VAT included, no per-cover fee, no matter how busy</a:t>
-            </a:r>
-          </a:p>
-        </p:txBody>
-      </p:sp>
-      <p:sp>
-        <p:nvSpPr>
-          <p:cNvPr id="16" name="TextBox 15"/>
+              <a:t>Eat App prices: yearly billing (30% off), per restaurant.eatapp.co, 2026.</a:t>
+            </a:r>
+          </a:p>
+        </p:txBody>
+      </p:sp>
+      <p:sp>
+        <p:nvSpPr>
+          <p:cNvPr id="12" name="TextBox 11"/>
           <p:cNvSpPr txBox="1"/>
           <p:nvPr/>
         </p:nvSpPr>
         <p:spPr>
           <a:xfrm>
-            <a:off x="822960" y="5806440"/>
-            <a:ext cx="10515600" cy="548640"/>
+            <a:off x="11247120" y="6400800"/>
+            <a:ext cx="731520" cy="365760"/>
           </a:xfrm>
           <a:prstGeom prst="rect">
             <a:avLst/>
@@ -11919,48 +12869,6 @@
           </a:bodyPr>
           <a:lstStyle/>
           <a:p>
-            <a:pPr algn="ctr">
-              <a:spcBef>
-                <a:spcPts val="0"/>
-              </a:spcBef>
-              <a:spcAft>
-                <a:spcPts val="0"/>
-              </a:spcAft>
-            </a:pPr>
-            <a:r>
-              <a:rPr sz="1400" b="0" i="0">
-                <a:solidFill>
-                  <a:srgbClr val="F4F1EC"/>
-                </a:solidFill>
-                <a:latin typeface="Calibri"/>
-              </a:rPr>
-              <a:t>With DineEase your cost is predictable. The more diners we send you, the more you save versus commission models.</a:t>
-            </a:r>
-          </a:p>
-        </p:txBody>
-      </p:sp>
-      <p:sp>
-        <p:nvSpPr>
-          <p:cNvPr id="17" name="TextBox 16"/>
-          <p:cNvSpPr txBox="1"/>
-          <p:nvPr/>
-        </p:nvSpPr>
-        <p:spPr>
-          <a:xfrm>
-            <a:off x="11247120" y="6400800"/>
-            <a:ext cx="731520" cy="365760"/>
-          </a:xfrm>
-          <a:prstGeom prst="rect">
-            <a:avLst/>
-          </a:prstGeom>
-          <a:noFill/>
-        </p:spPr>
-        <p:txBody>
-          <a:bodyPr wrap="square" lIns="0" rIns="0" tIns="0" bIns="0">
-            <a:spAutoFit/>
-          </a:bodyPr>
-          <a:lstStyle/>
-          <a:p>
             <a:pPr algn="r">
               <a:spcBef>
                 <a:spcPts val="0"/>
@@ -11983,7 +12891,7 @@
       </p:sp>
       <p:sp>
         <p:nvSpPr>
-          <p:cNvPr id="18" name="TextBox 17"/>
+          <p:cNvPr id="13" name="TextBox 12"/>
           <p:cNvSpPr txBox="1"/>
           <p:nvPr/>
         </p:nvSpPr>

</xml_diff>

<commit_message>
Add PDF export; fix slide 9 title overflow
- Export DineEase-Partner-Presentation.pdf alongside the .pptx
- Shorten slide 9 title to one line so it no longer overlaps subtitle

Co-Authored-By: Claude Opus 4.8 <noreply@anthropic.com>
Claude-Session: https://claude.ai/code/session_01CyhSA8ZRVEByeRTLp2jTDH
</commit_message>
<xml_diff>
--- a/presentation/DineEase-Partner-Presentation.pptx
+++ b/presentation/DineEase-Partner-Presentation.pptx
@@ -12165,7 +12165,7 @@
                 </a:solidFill>
                 <a:latin typeface="Georgia"/>
               </a:rPr>
-              <a:t>DineEase vs Eat App — same idea, built for Cyprus</a:t>
+              <a:t>DineEase vs Eat App — built for Cyprus</a:t>
             </a:r>
           </a:p>
         </p:txBody>
@@ -12178,7 +12178,7 @@
         </p:nvSpPr>
         <p:spPr>
           <a:xfrm>
-            <a:off x="868680" y="1645920"/>
+            <a:off x="868680" y="1691640"/>
             <a:ext cx="10515600" cy="457200"/>
           </a:xfrm>
           <a:prstGeom prst="rect">

</xml_diff>